<commit_message>
Prioritise Day 2 cost and observability with realistic exercises
Align both days to 09:45-17:30. Add mandatory cost investigation and budget design, schema-specific KQL and fictional fallbacks, a team incident exercise, revised handouts and slide PDFs. Instructor transcripts remain outside the student release.

Co-authored-by: Copilot <223556219+Copilot@users.noreply.github.com>
</commit_message>
<xml_diff>
--- a/V2/Day 1/LBS_Azure_Day_1_Attendee.pptx
+++ b/V2/Day 1/LBS_Azure_Day_1_Attendee.pptx
@@ -21868,63 +21868,35 @@
           </a:bodyPr>
           <a:lstStyle/>
           <a:p>
-            <a:pPr>
-              <a:lnSpc>
-                <a:spcPct val="100000"/>
-              </a:lnSpc>
-              <a:spcAft>
-                <a:spcPts val="600"/>
-              </a:spcAft>
-              <a:defRPr sz="1800">
-                <a:solidFill>
-                  <a:srgbClr val="18334D"/>
-                </a:solidFill>
-                <a:latin typeface="Aptos"/>
-              </a:defRPr>
-            </a:pPr>
-            <a:r>
-              <a:rPr/>
-              <a:t>• Orientation + safety: 30-45 min</a:t>
-            </a:r>
-          </a:p>
-          <a:p>
-            <a:pPr>
-              <a:lnSpc>
-                <a:spcPct val="100000"/>
-              </a:lnSpc>
-              <a:spcAft>
-                <a:spcPts val="600"/>
-              </a:spcAft>
-              <a:defRPr sz="1800">
-                <a:solidFill>
-                  <a:srgbClr val="18334D"/>
-                </a:solidFill>
-                <a:latin typeface="Aptos"/>
-              </a:defRPr>
-            </a:pPr>
-            <a:r>
-              <a:rPr/>
-              <a:t>• SQL: 60-70 min including access</a:t>
-            </a:r>
-          </a:p>
-          <a:p>
-            <a:pPr>
-              <a:lnSpc>
-                <a:spcPct val="100000"/>
-              </a:lnSpc>
-              <a:spcAft>
-                <a:spcPts val="600"/>
-              </a:spcAft>
-              <a:defRPr sz="1800">
-                <a:solidFill>
-                  <a:srgbClr val="18334D"/>
-                </a:solidFill>
-                <a:latin typeface="Aptos"/>
-              </a:defRPr>
-            </a:pPr>
-            <a:r>
-              <a:rPr/>
-              <a:t>• Blob Storage: 50-65 min</a:t>
+            <a:r>
+              <a:rPr sz="1900">
+                <a:latin typeface="Arial"/>
+              </a:rPr>
+              <a:t>09:45-11:05 welcome + foundations + orientation</a:t>
+            </a:r>
+          </a:p>
+          <a:p>
+            <a:r>
+              <a:rPr sz="1900">
+                <a:latin typeface="Arial"/>
+              </a:rPr>
+              <a:t>11:05-12:20 SQL + paired cost decision</a:t>
+            </a:r>
+          </a:p>
+          <a:p>
+            <a:r>
+              <a:rPr sz="1900">
+                <a:latin typeface="Arial"/>
+              </a:rPr>
+              <a:t>12:20-12:35 break; 12:35-13:40 Blob</a:t>
+            </a:r>
+          </a:p>
+          <a:p>
+            <a:r>
+              <a:rPr sz="1900">
+                <a:latin typeface="Arial"/>
+              </a:rPr>
+              <a:t>13:40-14:25 lunch</a:t>
             </a:r>
           </a:p>
         </p:txBody>
@@ -22033,63 +22005,35 @@
           </a:bodyPr>
           <a:lstStyle/>
           <a:p>
-            <a:pPr>
-              <a:lnSpc>
-                <a:spcPct val="100000"/>
-              </a:lnSpc>
-              <a:spcAft>
-                <a:spcPts val="600"/>
-              </a:spcAft>
-              <a:defRPr sz="1800">
-                <a:solidFill>
-                  <a:srgbClr val="18334D"/>
-                </a:solidFill>
-                <a:latin typeface="Aptos"/>
-              </a:defRPr>
-            </a:pPr>
-            <a:r>
-              <a:rPr/>
-              <a:t>• Function: 60-75 min</a:t>
-            </a:r>
-          </a:p>
-          <a:p>
-            <a:pPr>
-              <a:lnSpc>
-                <a:spcPct val="100000"/>
-              </a:lnSpc>
-              <a:spcAft>
-                <a:spcPts val="600"/>
-              </a:spcAft>
-              <a:defRPr sz="1800">
-                <a:solidFill>
-                  <a:srgbClr val="18334D"/>
-                </a:solidFill>
-                <a:latin typeface="Aptos"/>
-              </a:defRPr>
-            </a:pPr>
-            <a:r>
-              <a:rPr/>
-              <a:t>• Logs / KQL: 40-50 min</a:t>
-            </a:r>
-          </a:p>
-          <a:p>
-            <a:pPr>
-              <a:lnSpc>
-                <a:spcPct val="100000"/>
-              </a:lnSpc>
-              <a:spcAft>
-                <a:spcPts val="600"/>
-              </a:spcAft>
-              <a:defRPr sz="1800">
-                <a:solidFill>
-                  <a:srgbClr val="18334D"/>
-                </a:solidFill>
-                <a:latin typeface="Aptos"/>
-              </a:defRPr>
-            </a:pPr>
-            <a:r>
-              <a:rPr/>
-              <a:t>• Practice, troubleshooting and recap: 30-45 min</a:t>
+            <a:r>
+              <a:rPr sz="1900">
+                <a:latin typeface="Arial"/>
+              </a:rPr>
+              <a:t>14:25-15:40 Function; 15:40-15:55 break</a:t>
+            </a:r>
+          </a:p>
+          <a:p>
+            <a:r>
+              <a:rPr sz="1900">
+                <a:latin typeface="Arial"/>
+              </a:rPr>
+              <a:t>15:55-16:50 Logs / KQL</a:t>
+            </a:r>
+          </a:p>
+          <a:p>
+            <a:r>
+              <a:rPr sz="1900">
+                <a:latin typeface="Arial"/>
+              </a:rPr>
+              <a:t>16:50-17:30 recap, costs and cleanup</a:t>
+            </a:r>
+          </a:p>
+          <a:p>
+            <a:r>
+              <a:rPr sz="1900">
+                <a:latin typeface="Arial"/>
+              </a:rPr>
+              <a:t>Optional UI only if time permits</a:t>
             </a:r>
           </a:p>
         </p:txBody>

</xml_diff>